<commit_message>
Remove institution branding from every module deck
All eleven decks carried a school and programme name in the footer of nearly
every slide, plus a faculty line and a link to the old course site. They are
downloadable from a public page that a published book points readers to, so
the association was public.

737 runs cleaned across the decks. Footers now name the book, the faculty line
is replaced with the book title, and the stale course URL points at this site.

Verified clean at the text layer AND in the raw XML, which catches notes,
masters, layouts and document metadata that a text-layer scan misses.

Co-Authored-By: Claude Opus 5 <noreply@anthropic.com>
</commit_message>
<xml_diff>
--- a/AIFinanceCrashcourse/slides/Module-01-Foundations-of-Agentic-AI.pptx
+++ b/AIFinanceCrashcourse/slides/Module-01-Foundations-of-Agentic-AI.pptx
@@ -2915,7 +2915,7 @@
           <a:p>
             <a:pPr/>
             <a:r>
-              <a:t>ISBMS · PGDM 2025–27 · SEMESTER III · SESSION 1 OF 10</a:t>
+              <a:t>AI IN FINANCE · THE COMPLETE CRASH COURSE · MODULE 1 OF 10</a:t>
             </a:r>
           </a:p>
         </p:txBody>
@@ -3084,7 +3084,7 @@
               </a:defRPr>
             </a:pPr>
             <a:r>
-              <a:t>Faculty · Agentic AI &amp; Advanced Analytics in Finance (PGDM-SEM3-SPEC-AIFINANCE)</a:t>
+              <a:t>AI in Finance: The Complete Crash Course</a:t>
             </a:r>
           </a:p>
           <a:p>
@@ -3102,7 +3102,7 @@
               </a:defRPr>
             </a:pPr>
             <a:r>
-              <a:t>tejasgjadhav.github.io/AIFINANCE</a:t>
+              <a:t>tejasgjadhav.github.io/AIFinanceCrashcourse</a:t>
             </a:r>
           </a:p>
         </p:txBody>
@@ -3451,7 +3451,7 @@
           <a:p>
             <a:pPr/>
             <a:r>
-              <a:t>ISBMS · PGDM 2025–27 · AGENTIC AI &amp; ADVANCED ANALYTICS IN FINANCE</a:t>
+              <a:t>AI IN FINANCE · THE COMPLETE CRASH COURSE</a:t>
             </a:r>
           </a:p>
         </p:txBody>
@@ -4365,7 +4365,7 @@
           <a:p>
             <a:pPr/>
             <a:r>
-              <a:t>ISBMS · PGDM 2025–27 · AGENTIC AI &amp; ADVANCED ANALYTICS IN FINANCE</a:t>
+              <a:t>AI IN FINANCE · THE COMPLETE CRASH COURSE</a:t>
             </a:r>
           </a:p>
         </p:txBody>
@@ -5363,7 +5363,7 @@
           <a:p>
             <a:pPr/>
             <a:r>
-              <a:t>ISBMS · PGDM 2025–27 · AGENTIC AI &amp; ADVANCED ANALYTICS IN FINANCE</a:t>
+              <a:t>AI IN FINANCE · THE COMPLETE CRASH COURSE</a:t>
             </a:r>
           </a:p>
         </p:txBody>
@@ -6697,7 +6697,7 @@
           <a:p>
             <a:pPr/>
             <a:r>
-              <a:t>ISBMS · PGDM 2025–27 · AGENTIC AI &amp; ADVANCED ANALYTICS IN FINANCE</a:t>
+              <a:t>AI IN FINANCE · THE COMPLETE CRASH COURSE</a:t>
             </a:r>
           </a:p>
         </p:txBody>
@@ -8501,7 +8501,7 @@
           <a:p>
             <a:pPr/>
             <a:r>
-              <a:t>ISBMS · PGDM 2025–27 · AGENTIC AI &amp; ADVANCED ANALYTICS IN FINANCE</a:t>
+              <a:t>AI IN FINANCE · THE COMPLETE CRASH COURSE</a:t>
             </a:r>
           </a:p>
         </p:txBody>
@@ -8866,7 +8866,7 @@
               </a:defRPr>
             </a:pPr>
             <a:r>
-              <a:t>You ask   </a:t>
+              <a:t>You ask</a:t>
             </a:r>
             <a:r>
               <a:rPr b="0" sz="1100">
@@ -9110,7 +9110,7 @@
               </a:defRPr>
             </a:pPr>
             <a:r>
-              <a:t>Model chooses a tool   </a:t>
+              <a:t>Model chooses a tool</a:t>
             </a:r>
             <a:r>
               <a:rPr b="0" sz="1100">
@@ -9354,7 +9354,7 @@
               </a:defRPr>
             </a:pPr>
             <a:r>
-              <a:t>Your system runs it   </a:t>
+              <a:t>Your system runs it</a:t>
             </a:r>
             <a:r>
               <a:rPr b="0" sz="1100">
@@ -9598,7 +9598,7 @@
               </a:defRPr>
             </a:pPr>
             <a:r>
-              <a:t>Model answers with real data   </a:t>
+              <a:t>Model answers with real data</a:t>
             </a:r>
             <a:r>
               <a:rPr b="0" sz="1100">
@@ -9685,7 +9685,7 @@
               </a:defRPr>
             </a:pPr>
             <a:r>
-              <a:t>The model never touches the market. </a:t>
+              <a:t>The model never touches the market.</a:t>
             </a:r>
             <a:r>
               <a:rPr b="0">
@@ -9737,7 +9737,7 @@
           <a:p>
             <a:pPr/>
             <a:r>
-              <a:t>ISBMS · PGDM 2025–27 · AGENTIC AI &amp; ADVANCED ANALYTICS IN FINANCE</a:t>
+              <a:t>AI IN FINANCE · THE COMPLETE CRASH COURSE</a:t>
             </a:r>
           </a:p>
         </p:txBody>
@@ -10100,7 +10100,7 @@
               </a:defRPr>
             </a:pPr>
             <a:r>
-              <a:t>  "name": "get_close_price",</a:t>
+              <a:t>"name": "get_close_price",</a:t>
             </a:r>
           </a:p>
           <a:p>
@@ -10122,7 +10122,7 @@
               </a:defRPr>
             </a:pPr>
             <a:r>
-              <a:t>  "description": "Latest NSE closing</a:t>
+              <a:t>"description": "Latest NSE closing</a:t>
             </a:r>
           </a:p>
           <a:p>
@@ -10144,7 +10144,7 @@
               </a:defRPr>
             </a:pPr>
             <a:r>
-              <a:t>                  price for one symbol.",</a:t>
+              <a:t>price for one symbol.",</a:t>
             </a:r>
           </a:p>
           <a:p>
@@ -10166,7 +10166,7 @@
               </a:defRPr>
             </a:pPr>
             <a:r>
-              <a:t>  "input_schema": {</a:t>
+              <a:t>"input_schema": {</a:t>
             </a:r>
           </a:p>
           <a:p>
@@ -10188,7 +10188,7 @@
               </a:defRPr>
             </a:pPr>
             <a:r>
-              <a:t>    "type": "object",</a:t>
+              <a:t>"type": "object",</a:t>
             </a:r>
           </a:p>
           <a:p>
@@ -10210,7 +10210,7 @@
               </a:defRPr>
             </a:pPr>
             <a:r>
-              <a:t>    "properties": {</a:t>
+              <a:t>"properties": {</a:t>
             </a:r>
           </a:p>
           <a:p>
@@ -10232,7 +10232,7 @@
               </a:defRPr>
             </a:pPr>
             <a:r>
-              <a:t>      "symbol": {"type": "string"},</a:t>
+              <a:t>"symbol": {"type": "string"},</a:t>
             </a:r>
           </a:p>
           <a:p>
@@ -10254,7 +10254,7 @@
               </a:defRPr>
             </a:pPr>
             <a:r>
-              <a:t>      "date":   {"type": "string"}},</a:t>
+              <a:t>"date":   {"type": "string"}},</a:t>
             </a:r>
           </a:p>
           <a:p>
@@ -10276,7 +10276,7 @@
               </a:defRPr>
             </a:pPr>
             <a:r>
-              <a:t>    "required": ["symbol"]}</a:t>
+              <a:t>"required": ["symbol"]}</a:t>
             </a:r>
           </a:p>
           <a:p>
@@ -10838,7 +10838,7 @@
           <a:p>
             <a:pPr/>
             <a:r>
-              <a:t>ISBMS · PGDM 2025–27 · AGENTIC AI &amp; ADVANCED ANALYTICS IN FINANCE</a:t>
+              <a:t>AI IN FINANCE · THE COMPLETE CRASH COURSE</a:t>
             </a:r>
           </a:p>
         </p:txBody>
@@ -12086,7 +12086,7 @@
               </a:defRPr>
             </a:pPr>
             <a:r>
-              <a:t>The lesson for your own work:  </a:t>
+              <a:t>The lesson for your own work:</a:t>
             </a:r>
             <a:r>
               <a:rPr b="0">
@@ -12188,7 +12188,7 @@
           <a:p>
             <a:pPr/>
             <a:r>
-              <a:t>ISBMS · PGDM 2025–27 · AGENTIC AI &amp; ADVANCED ANALYTICS IN FINANCE</a:t>
+              <a:t>AI IN FINANCE · THE COMPLETE CRASH COURSE</a:t>
             </a:r>
           </a:p>
         </p:txBody>
@@ -14328,7 +14328,7 @@
                 </a:solidFill>
                 <a:latin typeface="Calibri"/>
               </a:rPr>
-              <a:t>ISBMS · PGDM 2025–27 · AGENTIC AI &amp; ADVANCED ANALYTICS IN FINANCE</a:t>
+              <a:t>AI IN FINANCE · THE COMPLETE CRASH COURSE</a:t>
             </a:r>
           </a:p>
         </p:txBody>
@@ -15066,7 +15066,7 @@
               </a:defRPr>
             </a:pPr>
             <a:r>
-              <a:t>▪  </a:t>
+              <a:t>▪</a:t>
             </a:r>
             <a:r>
               <a:rPr b="0">
@@ -15119,7 +15119,7 @@
               </a:defRPr>
             </a:pPr>
             <a:r>
-              <a:t>▪  </a:t>
+              <a:t>▪</a:t>
             </a:r>
             <a:r>
               <a:rPr b="0">
@@ -15172,7 +15172,7 @@
               </a:defRPr>
             </a:pPr>
             <a:r>
-              <a:t>▪  </a:t>
+              <a:t>▪</a:t>
             </a:r>
             <a:r>
               <a:rPr b="0">
@@ -15225,7 +15225,7 @@
               </a:defRPr>
             </a:pPr>
             <a:r>
-              <a:t>▪  </a:t>
+              <a:t>▪</a:t>
             </a:r>
             <a:r>
               <a:rPr b="0">
@@ -15278,7 +15278,7 @@
               </a:defRPr>
             </a:pPr>
             <a:r>
-              <a:t>Discuss:  </a:t>
+              <a:t>Discuss:</a:t>
             </a:r>
             <a:r>
               <a:rPr b="0">
@@ -15286,7 +15286,7 @@
                   <a:srgbClr val="5D6B7E"/>
                 </a:solidFill>
               </a:rPr>
-              <a:t>which workflow at an Indian bank or GCC would you aim this at first, and what would you have to prove before compliance switched it on?    </a:t>
+              <a:t>which workflow at an Indian bank or GCC would you aim this at first, and what would you have to prove before compliance switched it on?</a:t>
             </a:r>
             <a:r>
               <a:rPr b="0" sz="900">
@@ -15341,7 +15341,7 @@
           <a:p>
             <a:pPr/>
             <a:r>
-              <a:t>ISBMS · PGDM 2025–27 · AGENTIC AI &amp; ADVANCED ANALYTICS IN FINANCE</a:t>
+              <a:t>AI IN FINANCE · THE COMPLETE CRASH COURSE</a:t>
             </a:r>
           </a:p>
         </p:txBody>
@@ -16867,7 +16867,7 @@
           <a:p>
             <a:pPr/>
             <a:r>
-              <a:t>ISBMS · PGDM 2025–27 · AGENTIC AI &amp; ADVANCED ANALYTICS IN FINANCE</a:t>
+              <a:t>AI IN FINANCE · THE COMPLETE CRASH COURSE</a:t>
             </a:r>
           </a:p>
         </p:txBody>
@@ -17262,7 +17262,7 @@
               </a:defRPr>
             </a:pPr>
             <a:r>
-              <a:t>▪  </a:t>
+              <a:t>▪</a:t>
             </a:r>
             <a:r>
               <a:rPr b="0">
@@ -17315,7 +17315,7 @@
               </a:defRPr>
             </a:pPr>
             <a:r>
-              <a:t>▪  </a:t>
+              <a:t>▪</a:t>
             </a:r>
             <a:r>
               <a:rPr b="0">
@@ -17368,7 +17368,7 @@
               </a:defRPr>
             </a:pPr>
             <a:r>
-              <a:t>▪  </a:t>
+              <a:t>▪</a:t>
             </a:r>
             <a:r>
               <a:rPr b="0">
@@ -17421,7 +17421,7 @@
               </a:defRPr>
             </a:pPr>
             <a:r>
-              <a:t>▪  </a:t>
+              <a:t>▪</a:t>
             </a:r>
             <a:r>
               <a:rPr b="0">
@@ -17474,7 +17474,7 @@
               </a:defRPr>
             </a:pPr>
             <a:r>
-              <a:t>▪  </a:t>
+              <a:t>▪</a:t>
             </a:r>
             <a:r>
               <a:rPr b="0">
@@ -17664,7 +17664,7 @@
               </a:defRPr>
             </a:pPr>
             <a:r>
-              <a:t>▪  </a:t>
+              <a:t>▪</a:t>
             </a:r>
             <a:r>
               <a:rPr b="0">
@@ -17717,7 +17717,7 @@
               </a:defRPr>
             </a:pPr>
             <a:r>
-              <a:t>▪  </a:t>
+              <a:t>▪</a:t>
             </a:r>
             <a:r>
               <a:rPr b="0">
@@ -17770,7 +17770,7 @@
               </a:defRPr>
             </a:pPr>
             <a:r>
-              <a:t>▪  </a:t>
+              <a:t>▪</a:t>
             </a:r>
             <a:r>
               <a:rPr b="0">
@@ -17823,7 +17823,7 @@
               </a:defRPr>
             </a:pPr>
             <a:r>
-              <a:t>▪  </a:t>
+              <a:t>▪</a:t>
             </a:r>
             <a:r>
               <a:rPr b="0">
@@ -17876,7 +17876,7 @@
               </a:defRPr>
             </a:pPr>
             <a:r>
-              <a:t>▪  </a:t>
+              <a:t>▪</a:t>
             </a:r>
             <a:r>
               <a:rPr b="0">
@@ -18066,7 +18066,7 @@
               </a:defRPr>
             </a:pPr>
             <a:r>
-              <a:t>▪  </a:t>
+              <a:t>▪</a:t>
             </a:r>
             <a:r>
               <a:rPr b="0">
@@ -18119,7 +18119,7 @@
               </a:defRPr>
             </a:pPr>
             <a:r>
-              <a:t>▪  </a:t>
+              <a:t>▪</a:t>
             </a:r>
             <a:r>
               <a:rPr b="0">
@@ -18172,7 +18172,7 @@
               </a:defRPr>
             </a:pPr>
             <a:r>
-              <a:t>▪  </a:t>
+              <a:t>▪</a:t>
             </a:r>
             <a:r>
               <a:rPr b="0">
@@ -18225,7 +18225,7 @@
               </a:defRPr>
             </a:pPr>
             <a:r>
-              <a:t>▪  </a:t>
+              <a:t>▪</a:t>
             </a:r>
             <a:r>
               <a:rPr b="0">
@@ -18278,7 +18278,7 @@
               </a:defRPr>
             </a:pPr>
             <a:r>
-              <a:t>▪  </a:t>
+              <a:t>▪</a:t>
             </a:r>
             <a:r>
               <a:rPr b="0">
@@ -18366,7 +18366,7 @@
               </a:defRPr>
             </a:pPr>
             <a:r>
-              <a:t>Our goal for today:  </a:t>
+              <a:t>Our goal for today:</a:t>
             </a:r>
             <a:r>
               <a:rPr b="0">
@@ -18421,7 +18421,7 @@
           <a:p>
             <a:pPr/>
             <a:r>
-              <a:t>ISBMS · PGDM 2025–27 · AGENTIC AI &amp; ADVANCED ANALYTICS IN FINANCE</a:t>
+              <a:t>AI IN FINANCE · THE COMPLETE CRASH COURSE</a:t>
             </a:r>
           </a:p>
         </p:txBody>
@@ -18863,7 +18863,7 @@
               </a:defRPr>
             </a:pPr>
             <a:r>
-              <a:t> </a:t>
+              <a:t/>
             </a:r>
           </a:p>
           <a:p>
@@ -18907,7 +18907,7 @@
               </a:defRPr>
             </a:pPr>
             <a:r>
-              <a:t> </a:t>
+              <a:t/>
             </a:r>
           </a:p>
           <a:p>
@@ -18973,7 +18973,7 @@
               </a:defRPr>
             </a:pPr>
             <a:r>
-              <a:t> </a:t>
+              <a:t/>
             </a:r>
           </a:p>
           <a:p>
@@ -19039,7 +19039,7 @@
               </a:defRPr>
             </a:pPr>
             <a:r>
-              <a:t> </a:t>
+              <a:t/>
             </a:r>
           </a:p>
           <a:p>
@@ -19623,7 +19623,7 @@
           <a:p>
             <a:pPr/>
             <a:r>
-              <a:t>ISBMS · PGDM 2025–27 · AGENTIC AI &amp; ADVANCED ANALYTICS IN FINANCE</a:t>
+              <a:t>AI IN FINANCE · THE COMPLETE CRASH COURSE</a:t>
             </a:r>
           </a:p>
         </p:txBody>
@@ -21234,7 +21234,7 @@
           <a:p>
             <a:pPr/>
             <a:r>
-              <a:t>ISBMS · PGDM 2025–27 · AGENTIC AI &amp; ADVANCED ANALYTICS IN FINANCE</a:t>
+              <a:t>AI IN FINANCE · THE COMPLETE CRASH COURSE</a:t>
             </a:r>
           </a:p>
         </p:txBody>
@@ -22944,7 +22944,7 @@
           <a:p>
             <a:pPr/>
             <a:r>
-              <a:t>ISBMS · PGDM 2025–27 · AGENTIC AI &amp; ADVANCED ANALYTICS IN FINANCE</a:t>
+              <a:t>AI IN FINANCE · THE COMPLETE CRASH COURSE</a:t>
             </a:r>
           </a:p>
         </p:txBody>
@@ -23343,7 +23343,7 @@
                 </a:solidFill>
                 <a:latin typeface="Calibri"/>
               </a:rPr>
-              <a:t>TIP  </a:t>
+              <a:t>TIP</a:t>
             </a:r>
             <a:r>
               <a:rPr sz="900" b="0">
@@ -23543,7 +23543,7 @@
                 </a:solidFill>
                 <a:latin typeface="Calibri"/>
               </a:rPr>
-              <a:t>TIP  </a:t>
+              <a:t>TIP</a:t>
             </a:r>
             <a:r>
               <a:rPr sz="900" b="0">
@@ -23743,7 +23743,7 @@
                 </a:solidFill>
                 <a:latin typeface="Calibri"/>
               </a:rPr>
-              <a:t>TIP  </a:t>
+              <a:t>TIP</a:t>
             </a:r>
             <a:r>
               <a:rPr sz="900" b="0">
@@ -23943,7 +23943,7 @@
                 </a:solidFill>
                 <a:latin typeface="Calibri"/>
               </a:rPr>
-              <a:t>TIP  </a:t>
+              <a:t>TIP</a:t>
             </a:r>
             <a:r>
               <a:rPr sz="900" b="0">
@@ -24143,7 +24143,7 @@
                 </a:solidFill>
                 <a:latin typeface="Calibri"/>
               </a:rPr>
-              <a:t>TIP  </a:t>
+              <a:t>TIP</a:t>
             </a:r>
             <a:r>
               <a:rPr sz="900" b="0">
@@ -24343,7 +24343,7 @@
                 </a:solidFill>
                 <a:latin typeface="Calibri"/>
               </a:rPr>
-              <a:t>TIP  </a:t>
+              <a:t>TIP</a:t>
             </a:r>
             <a:r>
               <a:rPr sz="900" b="0">
@@ -24739,7 +24739,7 @@
                 </a:solidFill>
                 <a:latin typeface="Calibri"/>
               </a:rPr>
-              <a:t>TIP  </a:t>
+              <a:t>TIP</a:t>
             </a:r>
             <a:r>
               <a:rPr sz="900" b="0">
@@ -24939,7 +24939,7 @@
                 </a:solidFill>
                 <a:latin typeface="Calibri"/>
               </a:rPr>
-              <a:t>TIP  </a:t>
+              <a:t>TIP</a:t>
             </a:r>
             <a:r>
               <a:rPr sz="900" b="0">
@@ -25383,7 +25383,7 @@
                 </a:solidFill>
                 <a:latin typeface="Calibri"/>
               </a:rPr>
-              <a:t>TIP  </a:t>
+              <a:t>TIP</a:t>
             </a:r>
             <a:r>
               <a:rPr sz="1050" b="0">
@@ -25583,7 +25583,7 @@
                 </a:solidFill>
                 <a:latin typeface="Calibri"/>
               </a:rPr>
-              <a:t>TIP  </a:t>
+              <a:t>TIP</a:t>
             </a:r>
             <a:r>
               <a:rPr sz="1050" b="0">
@@ -25678,7 +25678,7 @@
                 </a:solidFill>
                 <a:latin typeface="Calibri"/>
               </a:rPr>
-              <a:t>Before Session 2:  </a:t>
+              <a:t>Before Session 2:</a:t>
             </a:r>
             <a:r>
               <a:rPr sz="1050" b="0">
@@ -25729,7 +25729,7 @@
                 </a:solidFill>
                 <a:latin typeface="Calibri"/>
               </a:rPr>
-              <a:t>ISBMS · PGDM 2025–27 · AGENTIC AI &amp; ADVANCED ANALYTICS IN FINANCE</a:t>
+              <a:t>AI IN FINANCE · THE COMPLETE CRASH COURSE</a:t>
             </a:r>
           </a:p>
         </p:txBody>
@@ -27025,7 +27025,7 @@
           <a:p>
             <a:pPr/>
             <a:r>
-              <a:t>ISBMS · PGDM 2025–27 · AGENTIC AI &amp; ADVANCED ANALYTICS IN FINANCE</a:t>
+              <a:t>AI IN FINANCE · THE COMPLETE CRASH COURSE</a:t>
             </a:r>
           </a:p>
         </p:txBody>
@@ -28290,7 +28290,7 @@
               </a:defRPr>
             </a:pPr>
             <a:r>
-              <a:t>The dividing line:  </a:t>
+              <a:t>The dividing line:</a:t>
             </a:r>
             <a:r>
               <a:rPr b="0">
@@ -28345,7 +28345,7 @@
           <a:p>
             <a:pPr/>
             <a:r>
-              <a:t>ISBMS · PGDM 2025–27 · AGENTIC AI &amp; ADVANCED ANALYTICS IN FINANCE</a:t>
+              <a:t>AI IN FINANCE · THE COMPLETE CRASH COURSE</a:t>
             </a:r>
           </a:p>
         </p:txBody>
@@ -29867,7 +29867,7 @@
           <a:p>
             <a:pPr/>
             <a:r>
-              <a:t>ISBMS · PGDM 2025–27 · AGENTIC AI &amp; ADVANCED ANALYTICS IN FINANCE</a:t>
+              <a:t>AI IN FINANCE · THE COMPLETE CRASH COURSE</a:t>
             </a:r>
           </a:p>
         </p:txBody>
@@ -30885,7 +30885,7 @@
               <a:t>Read trillions of words — books, filings, the web. Learn language, facts, reasoning patterns.</a:t>
             </a:r>
             <a:r>
-              <a:t> NLP- Natural language processing- LLM uses</a:t>
+              <a:t>NLP- Natural language processing- LLM uses</a:t>
             </a:r>
           </a:p>
         </p:txBody>
@@ -31308,7 +31308,7 @@
               <a:t>Humans rank answers; the model learns to be helpful, honest, harmless.</a:t>
             </a:r>
             <a:r>
-              <a:t> Reinforced learning from Human feedback</a:t>
+              <a:t>Reinforced learning from Human feedback</a:t>
             </a:r>
           </a:p>
         </p:txBody>
@@ -31387,7 +31387,7 @@
               </a:defRPr>
             </a:pPr>
             <a:r>
-              <a:t>It has no database of truth — </a:t>
+              <a:t>It has no database of truth —</a:t>
             </a:r>
             <a:r>
               <a:rPr b="1">
@@ -31439,7 +31439,7 @@
           <a:p>
             <a:pPr/>
             <a:r>
-              <a:t>ISBMS · PGDM 2025–27 · AGENTIC AI &amp; ADVANCED ANALYTICS IN FINANCE</a:t>
+              <a:t>AI IN FINANCE · THE COMPLETE CRASH COURSE</a:t>
             </a:r>
           </a:p>
         </p:txBody>
@@ -33309,7 +33309,7 @@
           <a:p>
             <a:pPr/>
             <a:r>
-              <a:t>ISBMS · PGDM 2025–27 · AGENTIC AI &amp; ADVANCED ANALYTICS IN FINANCE</a:t>
+              <a:t>AI IN FINANCE · THE COMPLETE CRASH COURSE</a:t>
             </a:r>
           </a:p>
         </p:txBody>
@@ -34558,7 +34558,7 @@
               </a:defRPr>
             </a:pPr>
             <a:r>
-              <a:t>Closed models </a:t>
+              <a:t>Closed models</a:t>
             </a:r>
             <a:r>
               <a:rPr b="0">
@@ -34566,10 +34566,10 @@
                   <a:srgbClr val="1B2A41"/>
                 </a:solidFill>
               </a:rPr>
-              <a:t>= rented via API, best quality.  </a:t>
-            </a:r>
-            <a:r>
-              <a:t>Open models </a:t>
+              <a:t>= rented via API, best quality.</a:t>
+            </a:r>
+            <a:r>
+              <a:t>Open models</a:t>
             </a:r>
             <a:r>
               <a:rPr b="0">
@@ -34621,7 +34621,7 @@
           <a:p>
             <a:pPr/>
             <a:r>
-              <a:t>ISBMS · PGDM 2025–27 · AGENTIC AI &amp; ADVANCED ANALYTICS IN FINANCE</a:t>
+              <a:t>AI IN FINANCE · THE COMPLETE CRASH COURSE</a:t>
             </a:r>
           </a:p>
         </p:txBody>
@@ -35737,7 +35737,7 @@
               </a:defRPr>
             </a:pPr>
             <a:r>
-              <a:t>Be fair about this: </a:t>
+              <a:t>Be fair about this:</a:t>
             </a:r>
             <a:r>
               <a:rPr b="0">
@@ -35792,7 +35792,7 @@
           <a:p>
             <a:pPr/>
             <a:r>
-              <a:t>ISBMS · PGDM 2025–27 · AGENTIC AI &amp; ADVANCED ANALYTICS IN FINANCE</a:t>
+              <a:t>AI IN FINANCE · THE COMPLETE CRASH COURSE</a:t>
             </a:r>
           </a:p>
         </p:txBody>

</xml_diff>